<commit_message>
feat: add listing detail, authentication pages, and core UI components
</commit_message>
<xml_diff>
--- a/docs/Vmax_mn_Platform_Presentation.pptx
+++ b/docs/Vmax_mn_Platform_Presentation.pptx
@@ -5,18 +5,19 @@
     <p:sldMasterId id="2147483648" r:id="rId1"/>
   </p:sldMasterIdLst>
   <p:sldIdLst>
-    <p:sldId id="256" r:id="rId7"/>
-    <p:sldId id="257" r:id="rId8"/>
-    <p:sldId id="258" r:id="rId9"/>
-    <p:sldId id="259" r:id="rId10"/>
-    <p:sldId id="260" r:id="rId11"/>
-    <p:sldId id="261" r:id="rId12"/>
-    <p:sldId id="262" r:id="rId13"/>
-    <p:sldId id="263" r:id="rId14"/>
-    <p:sldId id="264" r:id="rId15"/>
-    <p:sldId id="265" r:id="rId16"/>
+    <p:sldId id="256" r:id="rId2"/>
+    <p:sldId id="257" r:id="rId3"/>
+    <p:sldId id="258" r:id="rId4"/>
+    <p:sldId id="259" r:id="rId5"/>
+    <p:sldId id="260" r:id="rId6"/>
+    <p:sldId id="261" r:id="rId7"/>
+    <p:sldId id="262" r:id="rId8"/>
+    <p:sldId id="263" r:id="rId9"/>
+    <p:sldId id="264" r:id="rId10"/>
+    <p:sldId id="265" r:id="rId11"/>
+    <p:sldId id="266" r:id="rId12"/>
   </p:sldIdLst>
-  <p:sldSz cx="12191695" cy="6858000" type="screen4x3"/>
+  <p:sldSz cx="12192000" cy="6858000"/>
   <p:notesSz cx="6858000" cy="9144000"/>
   <p:defaultTextStyle>
     <a:defPPr>
@@ -113,6 +114,22 @@
       </a:defRPr>
     </a:lvl9pPr>
   </p:defaultTextStyle>
+  <p:extLst>
+    <p:ext uri="{EFAFB233-063F-42B5-8137-9DF3F51BA10A}">
+      <p15:sldGuideLst xmlns:p15="http://schemas.microsoft.com/office/powerpoint/2012/main">
+        <p15:guide id="1" orient="horz" pos="2160">
+          <p15:clr>
+            <a:srgbClr val="A4A3A4"/>
+          </p15:clr>
+        </p15:guide>
+        <p15:guide id="2" pos="2880">
+          <p15:clr>
+            <a:srgbClr val="A4A3A4"/>
+          </p15:clr>
+        </p15:guide>
+      </p15:sldGuideLst>
+    </p:ext>
+  </p:extLst>
 </p:presentation>
 </file>
 
@@ -154,10 +171,9 @@
           <a:lstStyle/>
           <a:p>
             <a:r>
-              <a:rPr lang="en-US" smtClean="0"/>
+              <a:rPr lang="en-US"/>
               <a:t>Click to edit Master title style</a:t>
             </a:r>
-            <a:endParaRPr lang="en-US"/>
           </a:p>
         </p:txBody>
       </p:sp>
@@ -273,10 +289,9 @@
           </a:lstStyle>
           <a:p>
             <a:r>
-              <a:rPr lang="en-US" smtClean="0"/>
+              <a:rPr lang="en-US"/>
               <a:t>Click to edit Master subtitle style</a:t>
             </a:r>
-            <a:endParaRPr lang="en-US"/>
           </a:p>
         </p:txBody>
       </p:sp>
@@ -297,7 +312,7 @@
           <a:p>
             <a:fld id="{5BCAD085-E8A6-8845-BD4E-CB4CCA059FC4}" type="datetimeFigureOut">
               <a:rPr lang="en-US" smtClean="0"/>
-              <a:t>1/27/13</a:t>
+              <a:t>10/11/2026</a:t>
             </a:fld>
             <a:endParaRPr lang="en-US"/>
           </a:p>
@@ -391,10 +406,9 @@
           <a:lstStyle/>
           <a:p>
             <a:r>
-              <a:rPr lang="en-US" smtClean="0"/>
+              <a:rPr lang="en-US"/>
               <a:t>Click to edit Master title style</a:t>
             </a:r>
-            <a:endParaRPr lang="en-US"/>
           </a:p>
         </p:txBody>
       </p:sp>
@@ -415,38 +429,37 @@
           <a:p>
             <a:pPr lvl="0"/>
             <a:r>
-              <a:rPr lang="en-US" smtClean="0"/>
+              <a:rPr lang="en-US"/>
               <a:t>Click to edit Master text styles</a:t>
             </a:r>
           </a:p>
           <a:p>
             <a:pPr lvl="1"/>
             <a:r>
-              <a:rPr lang="en-US" smtClean="0"/>
+              <a:rPr lang="en-US"/>
               <a:t>Second level</a:t>
             </a:r>
           </a:p>
           <a:p>
             <a:pPr lvl="2"/>
             <a:r>
-              <a:rPr lang="en-US" smtClean="0"/>
+              <a:rPr lang="en-US"/>
               <a:t>Third level</a:t>
             </a:r>
           </a:p>
           <a:p>
             <a:pPr lvl="3"/>
             <a:r>
-              <a:rPr lang="en-US" smtClean="0"/>
+              <a:rPr lang="en-US"/>
               <a:t>Fourth level</a:t>
             </a:r>
           </a:p>
           <a:p>
             <a:pPr lvl="4"/>
             <a:r>
-              <a:rPr lang="en-US" smtClean="0"/>
+              <a:rPr lang="en-US"/>
               <a:t>Fifth level</a:t>
             </a:r>
-            <a:endParaRPr lang="en-US"/>
           </a:p>
         </p:txBody>
       </p:sp>
@@ -467,7 +480,7 @@
           <a:p>
             <a:fld id="{5BCAD085-E8A6-8845-BD4E-CB4CCA059FC4}" type="datetimeFigureOut">
               <a:rPr lang="en-US" smtClean="0"/>
-              <a:t>1/27/13</a:t>
+              <a:t>10/11/2026</a:t>
             </a:fld>
             <a:endParaRPr lang="en-US"/>
           </a:p>
@@ -566,10 +579,9 @@
           <a:lstStyle/>
           <a:p>
             <a:r>
-              <a:rPr lang="en-US" smtClean="0"/>
+              <a:rPr lang="en-US"/>
               <a:t>Click to edit Master title style</a:t>
             </a:r>
-            <a:endParaRPr lang="en-US"/>
           </a:p>
         </p:txBody>
       </p:sp>
@@ -595,38 +607,37 @@
           <a:p>
             <a:pPr lvl="0"/>
             <a:r>
-              <a:rPr lang="en-US" smtClean="0"/>
+              <a:rPr lang="en-US"/>
               <a:t>Click to edit Master text styles</a:t>
             </a:r>
           </a:p>
           <a:p>
             <a:pPr lvl="1"/>
             <a:r>
-              <a:rPr lang="en-US" smtClean="0"/>
+              <a:rPr lang="en-US"/>
               <a:t>Second level</a:t>
             </a:r>
           </a:p>
           <a:p>
             <a:pPr lvl="2"/>
             <a:r>
-              <a:rPr lang="en-US" smtClean="0"/>
+              <a:rPr lang="en-US"/>
               <a:t>Third level</a:t>
             </a:r>
           </a:p>
           <a:p>
             <a:pPr lvl="3"/>
             <a:r>
-              <a:rPr lang="en-US" smtClean="0"/>
+              <a:rPr lang="en-US"/>
               <a:t>Fourth level</a:t>
             </a:r>
           </a:p>
           <a:p>
             <a:pPr lvl="4"/>
             <a:r>
-              <a:rPr lang="en-US" smtClean="0"/>
+              <a:rPr lang="en-US"/>
               <a:t>Fifth level</a:t>
             </a:r>
-            <a:endParaRPr lang="en-US"/>
           </a:p>
         </p:txBody>
       </p:sp>
@@ -647,7 +658,7 @@
           <a:p>
             <a:fld id="{5BCAD085-E8A6-8845-BD4E-CB4CCA059FC4}" type="datetimeFigureOut">
               <a:rPr lang="en-US" smtClean="0"/>
-              <a:t>1/27/13</a:t>
+              <a:t>10/11/2026</a:t>
             </a:fld>
             <a:endParaRPr lang="en-US"/>
           </a:p>
@@ -741,10 +752,9 @@
           <a:lstStyle/>
           <a:p>
             <a:r>
-              <a:rPr lang="en-US" smtClean="0"/>
+              <a:rPr lang="en-US"/>
               <a:t>Click to edit Master title style</a:t>
             </a:r>
-            <a:endParaRPr lang="en-US"/>
           </a:p>
         </p:txBody>
       </p:sp>
@@ -765,38 +775,37 @@
           <a:p>
             <a:pPr lvl="0"/>
             <a:r>
-              <a:rPr lang="en-US" smtClean="0"/>
+              <a:rPr lang="en-US"/>
               <a:t>Click to edit Master text styles</a:t>
             </a:r>
           </a:p>
           <a:p>
             <a:pPr lvl="1"/>
             <a:r>
-              <a:rPr lang="en-US" smtClean="0"/>
+              <a:rPr lang="en-US"/>
               <a:t>Second level</a:t>
             </a:r>
           </a:p>
           <a:p>
             <a:pPr lvl="2"/>
             <a:r>
-              <a:rPr lang="en-US" smtClean="0"/>
+              <a:rPr lang="en-US"/>
               <a:t>Third level</a:t>
             </a:r>
           </a:p>
           <a:p>
             <a:pPr lvl="3"/>
             <a:r>
-              <a:rPr lang="en-US" smtClean="0"/>
+              <a:rPr lang="en-US"/>
               <a:t>Fourth level</a:t>
             </a:r>
           </a:p>
           <a:p>
             <a:pPr lvl="4"/>
             <a:r>
-              <a:rPr lang="en-US" smtClean="0"/>
+              <a:rPr lang="en-US"/>
               <a:t>Fifth level</a:t>
             </a:r>
-            <a:endParaRPr lang="en-US"/>
           </a:p>
         </p:txBody>
       </p:sp>
@@ -817,7 +826,7 @@
           <a:p>
             <a:fld id="{5BCAD085-E8A6-8845-BD4E-CB4CCA059FC4}" type="datetimeFigureOut">
               <a:rPr lang="en-US" smtClean="0"/>
-              <a:t>1/27/13</a:t>
+              <a:t>10/11/2026</a:t>
             </a:fld>
             <a:endParaRPr lang="en-US"/>
           </a:p>
@@ -920,10 +929,9 @@
           </a:lstStyle>
           <a:p>
             <a:r>
-              <a:rPr lang="en-US" smtClean="0"/>
+              <a:rPr lang="en-US"/>
               <a:t>Click to edit Master title style</a:t>
             </a:r>
-            <a:endParaRPr lang="en-US"/>
           </a:p>
         </p:txBody>
       </p:sp>
@@ -1040,7 +1048,7 @@
           <a:p>
             <a:pPr lvl="0"/>
             <a:r>
-              <a:rPr lang="en-US" smtClean="0"/>
+              <a:rPr lang="en-US"/>
               <a:t>Click to edit Master text styles</a:t>
             </a:r>
           </a:p>
@@ -1063,7 +1071,7 @@
           <a:p>
             <a:fld id="{5BCAD085-E8A6-8845-BD4E-CB4CCA059FC4}" type="datetimeFigureOut">
               <a:rPr lang="en-US" smtClean="0"/>
-              <a:t>1/27/13</a:t>
+              <a:t>10/11/2026</a:t>
             </a:fld>
             <a:endParaRPr lang="en-US"/>
           </a:p>
@@ -1157,10 +1165,9 @@
           <a:lstStyle/>
           <a:p>
             <a:r>
-              <a:rPr lang="en-US" smtClean="0"/>
+              <a:rPr lang="en-US"/>
               <a:t>Click to edit Master title style</a:t>
             </a:r>
-            <a:endParaRPr lang="en-US"/>
           </a:p>
         </p:txBody>
       </p:sp>
@@ -1214,38 +1221,37 @@
           <a:p>
             <a:pPr lvl="0"/>
             <a:r>
-              <a:rPr lang="en-US" smtClean="0"/>
+              <a:rPr lang="en-US"/>
               <a:t>Click to edit Master text styles</a:t>
             </a:r>
           </a:p>
           <a:p>
             <a:pPr lvl="1"/>
             <a:r>
-              <a:rPr lang="en-US" smtClean="0"/>
+              <a:rPr lang="en-US"/>
               <a:t>Second level</a:t>
             </a:r>
           </a:p>
           <a:p>
             <a:pPr lvl="2"/>
             <a:r>
-              <a:rPr lang="en-US" smtClean="0"/>
+              <a:rPr lang="en-US"/>
               <a:t>Third level</a:t>
             </a:r>
           </a:p>
           <a:p>
             <a:pPr lvl="3"/>
             <a:r>
-              <a:rPr lang="en-US" smtClean="0"/>
+              <a:rPr lang="en-US"/>
               <a:t>Fourth level</a:t>
             </a:r>
           </a:p>
           <a:p>
             <a:pPr lvl="4"/>
             <a:r>
-              <a:rPr lang="en-US" smtClean="0"/>
+              <a:rPr lang="en-US"/>
               <a:t>Fifth level</a:t>
             </a:r>
-            <a:endParaRPr lang="en-US"/>
           </a:p>
         </p:txBody>
       </p:sp>
@@ -1299,38 +1305,37 @@
           <a:p>
             <a:pPr lvl="0"/>
             <a:r>
-              <a:rPr lang="en-US" smtClean="0"/>
+              <a:rPr lang="en-US"/>
               <a:t>Click to edit Master text styles</a:t>
             </a:r>
           </a:p>
           <a:p>
             <a:pPr lvl="1"/>
             <a:r>
-              <a:rPr lang="en-US" smtClean="0"/>
+              <a:rPr lang="en-US"/>
               <a:t>Second level</a:t>
             </a:r>
           </a:p>
           <a:p>
             <a:pPr lvl="2"/>
             <a:r>
-              <a:rPr lang="en-US" smtClean="0"/>
+              <a:rPr lang="en-US"/>
               <a:t>Third level</a:t>
             </a:r>
           </a:p>
           <a:p>
             <a:pPr lvl="3"/>
             <a:r>
-              <a:rPr lang="en-US" smtClean="0"/>
+              <a:rPr lang="en-US"/>
               <a:t>Fourth level</a:t>
             </a:r>
           </a:p>
           <a:p>
             <a:pPr lvl="4"/>
             <a:r>
-              <a:rPr lang="en-US" smtClean="0"/>
+              <a:rPr lang="en-US"/>
               <a:t>Fifth level</a:t>
             </a:r>
-            <a:endParaRPr lang="en-US"/>
           </a:p>
         </p:txBody>
       </p:sp>
@@ -1351,7 +1356,7 @@
           <a:p>
             <a:fld id="{5BCAD085-E8A6-8845-BD4E-CB4CCA059FC4}" type="datetimeFigureOut">
               <a:rPr lang="en-US" smtClean="0"/>
-              <a:t>1/27/13</a:t>
+              <a:t>10/11/2026</a:t>
             </a:fld>
             <a:endParaRPr lang="en-US"/>
           </a:p>
@@ -1449,10 +1454,9 @@
           </a:lstStyle>
           <a:p>
             <a:r>
-              <a:rPr lang="en-US" smtClean="0"/>
+              <a:rPr lang="en-US"/>
               <a:t>Click to edit Master title style</a:t>
             </a:r>
-            <a:endParaRPr lang="en-US"/>
           </a:p>
         </p:txBody>
       </p:sp>
@@ -1515,7 +1519,7 @@
           <a:p>
             <a:pPr lvl="0"/>
             <a:r>
-              <a:rPr lang="en-US" smtClean="0"/>
+              <a:rPr lang="en-US"/>
               <a:t>Click to edit Master text styles</a:t>
             </a:r>
           </a:p>
@@ -1571,38 +1575,37 @@
           <a:p>
             <a:pPr lvl="0"/>
             <a:r>
-              <a:rPr lang="en-US" smtClean="0"/>
+              <a:rPr lang="en-US"/>
               <a:t>Click to edit Master text styles</a:t>
             </a:r>
           </a:p>
           <a:p>
             <a:pPr lvl="1"/>
             <a:r>
-              <a:rPr lang="en-US" smtClean="0"/>
+              <a:rPr lang="en-US"/>
               <a:t>Second level</a:t>
             </a:r>
           </a:p>
           <a:p>
             <a:pPr lvl="2"/>
             <a:r>
-              <a:rPr lang="en-US" smtClean="0"/>
+              <a:rPr lang="en-US"/>
               <a:t>Third level</a:t>
             </a:r>
           </a:p>
           <a:p>
             <a:pPr lvl="3"/>
             <a:r>
-              <a:rPr lang="en-US" smtClean="0"/>
+              <a:rPr lang="en-US"/>
               <a:t>Fourth level</a:t>
             </a:r>
           </a:p>
           <a:p>
             <a:pPr lvl="4"/>
             <a:r>
-              <a:rPr lang="en-US" smtClean="0"/>
+              <a:rPr lang="en-US"/>
               <a:t>Fifth level</a:t>
             </a:r>
-            <a:endParaRPr lang="en-US"/>
           </a:p>
         </p:txBody>
       </p:sp>
@@ -1665,7 +1668,7 @@
           <a:p>
             <a:pPr lvl="0"/>
             <a:r>
-              <a:rPr lang="en-US" smtClean="0"/>
+              <a:rPr lang="en-US"/>
               <a:t>Click to edit Master text styles</a:t>
             </a:r>
           </a:p>
@@ -1721,38 +1724,37 @@
           <a:p>
             <a:pPr lvl="0"/>
             <a:r>
-              <a:rPr lang="en-US" smtClean="0"/>
+              <a:rPr lang="en-US"/>
               <a:t>Click to edit Master text styles</a:t>
             </a:r>
           </a:p>
           <a:p>
             <a:pPr lvl="1"/>
             <a:r>
-              <a:rPr lang="en-US" smtClean="0"/>
+              <a:rPr lang="en-US"/>
               <a:t>Second level</a:t>
             </a:r>
           </a:p>
           <a:p>
             <a:pPr lvl="2"/>
             <a:r>
-              <a:rPr lang="en-US" smtClean="0"/>
+              <a:rPr lang="en-US"/>
               <a:t>Third level</a:t>
             </a:r>
           </a:p>
           <a:p>
             <a:pPr lvl="3"/>
             <a:r>
-              <a:rPr lang="en-US" smtClean="0"/>
+              <a:rPr lang="en-US"/>
               <a:t>Fourth level</a:t>
             </a:r>
           </a:p>
           <a:p>
             <a:pPr lvl="4"/>
             <a:r>
-              <a:rPr lang="en-US" smtClean="0"/>
+              <a:rPr lang="en-US"/>
               <a:t>Fifth level</a:t>
             </a:r>
-            <a:endParaRPr lang="en-US"/>
           </a:p>
         </p:txBody>
       </p:sp>
@@ -1773,7 +1775,7 @@
           <a:p>
             <a:fld id="{5BCAD085-E8A6-8845-BD4E-CB4CCA059FC4}" type="datetimeFigureOut">
               <a:rPr lang="en-US" smtClean="0"/>
-              <a:t>1/27/13</a:t>
+              <a:t>10/11/2026</a:t>
             </a:fld>
             <a:endParaRPr lang="en-US"/>
           </a:p>
@@ -1867,10 +1869,9 @@
           <a:lstStyle/>
           <a:p>
             <a:r>
-              <a:rPr lang="en-US" smtClean="0"/>
+              <a:rPr lang="en-US"/>
               <a:t>Click to edit Master title style</a:t>
             </a:r>
-            <a:endParaRPr lang="en-US"/>
           </a:p>
         </p:txBody>
       </p:sp>
@@ -1891,7 +1892,7 @@
           <a:p>
             <a:fld id="{5BCAD085-E8A6-8845-BD4E-CB4CCA059FC4}" type="datetimeFigureOut">
               <a:rPr lang="en-US" smtClean="0"/>
-              <a:t>1/27/13</a:t>
+              <a:t>10/11/2026</a:t>
             </a:fld>
             <a:endParaRPr lang="en-US"/>
           </a:p>
@@ -1986,7 +1987,7 @@
           <a:p>
             <a:fld id="{5BCAD085-E8A6-8845-BD4E-CB4CCA059FC4}" type="datetimeFigureOut">
               <a:rPr lang="en-US" smtClean="0"/>
-              <a:t>1/27/13</a:t>
+              <a:t>10/11/2026</a:t>
             </a:fld>
             <a:endParaRPr lang="en-US"/>
           </a:p>
@@ -2089,10 +2090,9 @@
           </a:lstStyle>
           <a:p>
             <a:r>
-              <a:rPr lang="en-US" smtClean="0"/>
+              <a:rPr lang="en-US"/>
               <a:t>Click to edit Master title style</a:t>
             </a:r>
-            <a:endParaRPr lang="en-US"/>
           </a:p>
         </p:txBody>
       </p:sp>
@@ -2146,38 +2146,37 @@
           <a:p>
             <a:pPr lvl="0"/>
             <a:r>
-              <a:rPr lang="en-US" smtClean="0"/>
+              <a:rPr lang="en-US"/>
               <a:t>Click to edit Master text styles</a:t>
             </a:r>
           </a:p>
           <a:p>
             <a:pPr lvl="1"/>
             <a:r>
-              <a:rPr lang="en-US" smtClean="0"/>
+              <a:rPr lang="en-US"/>
               <a:t>Second level</a:t>
             </a:r>
           </a:p>
           <a:p>
             <a:pPr lvl="2"/>
             <a:r>
-              <a:rPr lang="en-US" smtClean="0"/>
+              <a:rPr lang="en-US"/>
               <a:t>Third level</a:t>
             </a:r>
           </a:p>
           <a:p>
             <a:pPr lvl="3"/>
             <a:r>
-              <a:rPr lang="en-US" smtClean="0"/>
+              <a:rPr lang="en-US"/>
               <a:t>Fourth level</a:t>
             </a:r>
           </a:p>
           <a:p>
             <a:pPr lvl="4"/>
             <a:r>
-              <a:rPr lang="en-US" smtClean="0"/>
+              <a:rPr lang="en-US"/>
               <a:t>Fifth level</a:t>
             </a:r>
-            <a:endParaRPr lang="en-US"/>
           </a:p>
         </p:txBody>
       </p:sp>
@@ -2240,7 +2239,7 @@
           <a:p>
             <a:pPr lvl="0"/>
             <a:r>
-              <a:rPr lang="en-US" smtClean="0"/>
+              <a:rPr lang="en-US"/>
               <a:t>Click to edit Master text styles</a:t>
             </a:r>
           </a:p>
@@ -2263,7 +2262,7 @@
           <a:p>
             <a:fld id="{5BCAD085-E8A6-8845-BD4E-CB4CCA059FC4}" type="datetimeFigureOut">
               <a:rPr lang="en-US" smtClean="0"/>
-              <a:t>1/27/13</a:t>
+              <a:t>10/11/2026</a:t>
             </a:fld>
             <a:endParaRPr lang="en-US"/>
           </a:p>
@@ -2366,10 +2365,9 @@
           </a:lstStyle>
           <a:p>
             <a:r>
-              <a:rPr lang="en-US" smtClean="0"/>
+              <a:rPr lang="en-US"/>
               <a:t>Click to edit Master title style</a:t>
             </a:r>
-            <a:endParaRPr lang="en-US"/>
           </a:p>
         </p:txBody>
       </p:sp>
@@ -2493,7 +2491,7 @@
           <a:p>
             <a:pPr lvl="0"/>
             <a:r>
-              <a:rPr lang="en-US" smtClean="0"/>
+              <a:rPr lang="en-US"/>
               <a:t>Click to edit Master text styles</a:t>
             </a:r>
           </a:p>
@@ -2516,7 +2514,7 @@
           <a:p>
             <a:fld id="{5BCAD085-E8A6-8845-BD4E-CB4CCA059FC4}" type="datetimeFigureOut">
               <a:rPr lang="en-US" smtClean="0"/>
-              <a:t>1/27/13</a:t>
+              <a:t>10/11/2026</a:t>
             </a:fld>
             <a:endParaRPr lang="en-US"/>
           </a:p>
@@ -2625,10 +2623,9 @@
           <a:lstStyle/>
           <a:p>
             <a:r>
-              <a:rPr lang="en-US" smtClean="0"/>
+              <a:rPr lang="en-US"/>
               <a:t>Click to edit Master title style</a:t>
             </a:r>
-            <a:endParaRPr lang="en-US"/>
           </a:p>
         </p:txBody>
       </p:sp>
@@ -2659,38 +2656,37 @@
           <a:p>
             <a:pPr lvl="0"/>
             <a:r>
-              <a:rPr lang="en-US" smtClean="0"/>
+              <a:rPr lang="en-US"/>
               <a:t>Click to edit Master text styles</a:t>
             </a:r>
           </a:p>
           <a:p>
             <a:pPr lvl="1"/>
             <a:r>
-              <a:rPr lang="en-US" smtClean="0"/>
+              <a:rPr lang="en-US"/>
               <a:t>Second level</a:t>
             </a:r>
           </a:p>
           <a:p>
             <a:pPr lvl="2"/>
             <a:r>
-              <a:rPr lang="en-US" smtClean="0"/>
+              <a:rPr lang="en-US"/>
               <a:t>Third level</a:t>
             </a:r>
           </a:p>
           <a:p>
             <a:pPr lvl="3"/>
             <a:r>
-              <a:rPr lang="en-US" smtClean="0"/>
+              <a:rPr lang="en-US"/>
               <a:t>Fourth level</a:t>
             </a:r>
           </a:p>
           <a:p>
             <a:pPr lvl="4"/>
             <a:r>
-              <a:rPr lang="en-US" smtClean="0"/>
+              <a:rPr lang="en-US"/>
               <a:t>Fifth level</a:t>
             </a:r>
-            <a:endParaRPr lang="en-US"/>
           </a:p>
         </p:txBody>
       </p:sp>
@@ -2729,7 +2725,7 @@
           <a:p>
             <a:fld id="{5BCAD085-E8A6-8845-BD4E-CB4CCA059FC4}" type="datetimeFigureOut">
               <a:rPr lang="en-US" smtClean="0"/>
-              <a:t>1/27/13</a:t>
+              <a:t>10/11/2026</a:t>
             </a:fld>
             <a:endParaRPr lang="en-US"/>
           </a:p>
@@ -3088,7 +3084,7 @@
 </file>
 
 <file path=ppt/slides/slide1.xml><?xml version="1.0" encoding="utf-8"?>
-<p:sld xmlns:a="http://schemas.openxmlformats.org/drawingml/2006/main" xmlns:p="http://schemas.openxmlformats.org/presentationml/2006/main" xmlns:r="http://schemas.openxmlformats.org/officeDocument/2006/relationships">
+<p:sld xmlns:a="http://schemas.openxmlformats.org/drawingml/2006/main" xmlns:r="http://schemas.openxmlformats.org/officeDocument/2006/relationships" xmlns:p="http://schemas.openxmlformats.org/presentationml/2006/main">
   <p:cSld>
     <p:bg>
       <p:bgPr>
@@ -3104,7 +3100,14 @@
         <p:cNvGrpSpPr/>
         <p:nvPr/>
       </p:nvGrpSpPr>
-      <p:grpSpPr/>
+      <p:grpSpPr>
+        <a:xfrm>
+          <a:off x="0" y="0"/>
+          <a:ext cx="0" cy="0"/>
+          <a:chOff x="0" y="0"/>
+          <a:chExt cx="0" cy="0"/>
+        </a:xfrm>
+      </p:grpSpPr>
       <p:sp>
         <p:nvSpPr>
           <p:cNvPr id="2" name="Rounded Rectangle 1"/>
@@ -3143,7 +3146,7 @@
           </a:fontRef>
         </p:style>
         <p:txBody>
-          <a:bodyPr rtlCol="0" anchor="ctr" wrap="square" lIns="731520" tIns="731520"/>
+          <a:bodyPr wrap="square" lIns="731520" tIns="731520" rtlCol="0" anchor="ctr"/>
           <a:lstStyle/>
           <a:p>
             <a:pPr algn="ctr">
@@ -3217,7 +3220,7 @@
 </file>
 
 <file path=ppt/slides/slide10.xml><?xml version="1.0" encoding="utf-8"?>
-<p:sld xmlns:a="http://schemas.openxmlformats.org/drawingml/2006/main" xmlns:p="http://schemas.openxmlformats.org/presentationml/2006/main" xmlns:r="http://schemas.openxmlformats.org/officeDocument/2006/relationships">
+<p:sld xmlns:a="http://schemas.openxmlformats.org/drawingml/2006/main" xmlns:r="http://schemas.openxmlformats.org/officeDocument/2006/relationships" xmlns:p="http://schemas.openxmlformats.org/presentationml/2006/main">
   <p:cSld>
     <p:bg>
       <p:bgPr>
@@ -3233,7 +3236,14 @@
         <p:cNvGrpSpPr/>
         <p:nvPr/>
       </p:nvGrpSpPr>
-      <p:grpSpPr/>
+      <p:grpSpPr>
+        <a:xfrm>
+          <a:off x="0" y="0"/>
+          <a:ext cx="0" cy="0"/>
+          <a:chOff x="0" y="0"/>
+          <a:chExt cx="0" cy="0"/>
+        </a:xfrm>
+      </p:grpSpPr>
       <p:sp>
         <p:nvSpPr>
           <p:cNvPr id="2" name="TextBox 1"/>
@@ -3361,6 +3371,7 @@
           <a:lstStyle/>
           <a:p>
             <a:pPr algn="ctr"/>
+            <a:endParaRPr/>
           </a:p>
         </p:txBody>
       </p:sp>
@@ -3373,7 +3384,7 @@
         <p:spPr>
           <a:xfrm>
             <a:off x="1005840" y="1828800"/>
-            <a:ext cx="4572000" cy="3931920"/>
+            <a:ext cx="4572000" cy="630942"/>
           </a:xfrm>
           <a:prstGeom prst="rect">
             <a:avLst/>
@@ -3398,8 +3409,18 @@
               </a:defRPr>
             </a:pPr>
             <a:r>
-              <a:t>🌐 Олон Хэл &amp; Технологийн Хурд</a:t>
-            </a:r>
+              <a:rPr dirty="0"/>
+              <a:t>🌐</a:t>
+            </a:r>
+            <a:r>
+              <a:rPr lang="en-US" dirty="0"/>
+              <a:t> </a:t>
+            </a:r>
+            <a:r>
+              <a:rPr lang="mn-MN" dirty="0"/>
+              <a:t>Автомат мэдэгдэл хүлээн авах</a:t>
+            </a:r>
+            <a:endParaRPr dirty="0"/>
           </a:p>
           <a:p>
             <a:pPr>
@@ -3414,55 +3435,44 @@
               </a:defRPr>
             </a:pPr>
             <a:r>
-              <a:t>• Монгол ба Англи (MN / EN) хэлний сонголттай.</a:t>
-            </a:r>
-          </a:p>
-          <a:p>
-            <a:pPr>
-              <a:spcAft>
-                <a:spcPts val="800"/>
-              </a:spcAft>
-              <a:defRPr sz="1300">
-                <a:solidFill>
-                  <a:srgbClr val="FFFFFF"/>
-                </a:solidFill>
-                <a:latin typeface="Segoe UI"/>
-              </a:defRPr>
-            </a:pPr>
-            <a:r>
-              <a:t>• Гадаадын иргэд ба хөрөнгө оруулагчдад нээлттэй.</a:t>
-            </a:r>
-          </a:p>
-          <a:p>
-            <a:pPr>
-              <a:spcAft>
-                <a:spcPts val="800"/>
-              </a:spcAft>
-              <a:defRPr sz="1300">
-                <a:solidFill>
-                  <a:srgbClr val="FFFFFF"/>
-                </a:solidFill>
-                <a:latin typeface="Segoe UI"/>
-              </a:defRPr>
-            </a:pPr>
-            <a:r>
-              <a:t>• Single Page Application (SPA) - маш хурдан ажиллагаа.</a:t>
-            </a:r>
-          </a:p>
-          <a:p>
-            <a:pPr>
-              <a:spcAft>
-                <a:spcPts val="800"/>
-              </a:spcAft>
-              <a:defRPr sz="1300">
-                <a:solidFill>
-                  <a:srgbClr val="FFFFFF"/>
-                </a:solidFill>
-                <a:latin typeface="Segoe UI"/>
-              </a:defRPr>
-            </a:pPr>
-            <a:r>
-              <a:t>• Dark Cosmic өнгө төрх - Орчин үеийн премиум дизайн.</a:t>
+              <a:rPr dirty="0"/>
+              <a:t>• А</a:t>
+            </a:r>
+            <a:r>
+              <a:rPr lang="ru-RU" dirty="0"/>
+              <a:t>втомат </a:t>
+            </a:r>
+            <a:r>
+              <a:rPr dirty="0" err="1"/>
+              <a:t>мэдэгдэл</a:t>
+            </a:r>
+            <a:r>
+              <a:rPr dirty="0"/>
+              <a:t> </a:t>
+            </a:r>
+            <a:r>
+              <a:rPr dirty="0" err="1"/>
+              <a:t>хүлээн</a:t>
+            </a:r>
+            <a:r>
+              <a:rPr dirty="0"/>
+              <a:t> </a:t>
+            </a:r>
+            <a:r>
+              <a:rPr dirty="0" err="1"/>
+              <a:t>авах</a:t>
+            </a:r>
+            <a:r>
+              <a:rPr dirty="0"/>
+              <a:t> </a:t>
+            </a:r>
+            <a:r>
+              <a:rPr dirty="0" err="1"/>
+              <a:t>тохиргоо</a:t>
+            </a:r>
+            <a:r>
+              <a:rPr dirty="0"/>
+              <a:t>.</a:t>
             </a:r>
           </a:p>
         </p:txBody>
@@ -3509,6 +3519,7 @@
           <a:lstStyle/>
           <a:p>
             <a:pPr algn="ctr"/>
+            <a:endParaRPr/>
           </a:p>
         </p:txBody>
       </p:sp>
@@ -3521,7 +3532,7 @@
         <p:spPr>
           <a:xfrm>
             <a:off x="6613855" y="1828800"/>
-            <a:ext cx="4572000" cy="3931920"/>
+            <a:ext cx="4572000" cy="1333698"/>
           </a:xfrm>
           <a:prstGeom prst="rect">
             <a:avLst/>
@@ -3546,8 +3557,46 @@
               </a:defRPr>
             </a:pPr>
             <a:r>
-              <a:t>🏆 Товч Дүгнэлт ба Давуу Тал</a:t>
-            </a:r>
+              <a:rPr dirty="0"/>
+              <a:t>🏆 </a:t>
+            </a:r>
+            <a:r>
+              <a:rPr dirty="0" err="1"/>
+              <a:t>Товч</a:t>
+            </a:r>
+            <a:r>
+              <a:rPr dirty="0"/>
+              <a:t> </a:t>
+            </a:r>
+            <a:r>
+              <a:rPr dirty="0" err="1"/>
+              <a:t>Дүгнэлт</a:t>
+            </a:r>
+            <a:r>
+              <a:rPr dirty="0"/>
+              <a:t> </a:t>
+            </a:r>
+            <a:r>
+              <a:rPr dirty="0" err="1"/>
+              <a:t>ба</a:t>
+            </a:r>
+            <a:r>
+              <a:rPr dirty="0"/>
+              <a:t> </a:t>
+            </a:r>
+            <a:r>
+              <a:rPr dirty="0" err="1"/>
+              <a:t>Давуу</a:t>
+            </a:r>
+            <a:r>
+              <a:rPr dirty="0"/>
+              <a:t> </a:t>
+            </a:r>
+            <a:r>
+              <a:rPr dirty="0" err="1"/>
+              <a:t>Тал</a:t>
+            </a:r>
+            <a:endParaRPr dirty="0"/>
           </a:p>
           <a:p>
             <a:pPr>
@@ -3562,8 +3611,94 @@
               </a:defRPr>
             </a:pPr>
             <a:r>
-              <a:t>• ✅ 1 минутад зар нийтлэх &amp; 1 секундэд сошиал постер бүтээх.</a:t>
-            </a:r>
+              <a:rPr dirty="0"/>
+              <a:t>• ✅ </a:t>
+            </a:r>
+            <a:r>
+              <a:rPr dirty="0" err="1"/>
+              <a:t>Хайлтанд</a:t>
+            </a:r>
+            <a:r>
+              <a:rPr dirty="0"/>
+              <a:t> </a:t>
+            </a:r>
+            <a:r>
+              <a:rPr dirty="0" err="1"/>
+              <a:t>тохирох</a:t>
+            </a:r>
+            <a:r>
+              <a:rPr dirty="0"/>
+              <a:t> </a:t>
+            </a:r>
+            <a:r>
+              <a:rPr dirty="0" err="1"/>
+              <a:t>зар</a:t>
+            </a:r>
+            <a:r>
+              <a:rPr dirty="0"/>
+              <a:t> </a:t>
+            </a:r>
+            <a:r>
+              <a:rPr dirty="0" err="1"/>
+              <a:t>олдохгүй</a:t>
+            </a:r>
+            <a:r>
+              <a:rPr dirty="0"/>
+              <a:t> </a:t>
+            </a:r>
+            <a:r>
+              <a:rPr dirty="0" err="1"/>
+              <a:t>үед</a:t>
+            </a:r>
+            <a:r>
+              <a:rPr dirty="0"/>
+              <a:t> </a:t>
+            </a:r>
+            <a:r>
+              <a:rPr dirty="0" err="1"/>
+              <a:t>автомат</a:t>
+            </a:r>
+            <a:r>
+              <a:rPr dirty="0"/>
+              <a:t> </a:t>
+            </a:r>
+            <a:r>
+              <a:rPr dirty="0" err="1"/>
+              <a:t>мэдэгдэл</a:t>
+            </a:r>
+            <a:r>
+              <a:rPr dirty="0"/>
+              <a:t> </a:t>
+            </a:r>
+            <a:r>
+              <a:rPr dirty="0" err="1"/>
+              <a:t>зар</a:t>
+            </a:r>
+            <a:r>
+              <a:rPr dirty="0"/>
+              <a:t> </a:t>
+            </a:r>
+            <a:r>
+              <a:rPr dirty="0" err="1"/>
+              <a:t>оруулах</a:t>
+            </a:r>
+            <a:r>
+              <a:rPr dirty="0"/>
+              <a:t> </a:t>
+            </a:r>
+            <a:r>
+              <a:rPr dirty="0" err="1"/>
+              <a:t>тохиргоог</a:t>
+            </a:r>
+            <a:r>
+              <a:rPr dirty="0"/>
+              <a:t> </a:t>
+            </a:r>
+            <a:r>
+              <a:rPr dirty="0" err="1"/>
+              <a:t>ашиглах</a:t>
+            </a:r>
+            <a:endParaRPr dirty="0"/>
           </a:p>
           <a:p>
             <a:pPr>
@@ -3578,40 +3713,102 @@
               </a:defRPr>
             </a:pPr>
             <a:r>
-              <a:t>• ✅ Видео зар хавсаргаж худалдан авагчийн итгэлцлийг олох.</a:t>
-            </a:r>
-          </a:p>
-          <a:p>
-            <a:pPr>
-              <a:spcAft>
-                <a:spcPts val="800"/>
-              </a:spcAft>
-              <a:defRPr sz="1300">
-                <a:solidFill>
-                  <a:srgbClr val="FFFFFF"/>
-                </a:solidFill>
-                <a:latin typeface="Segoe UI"/>
-              </a:defRPr>
-            </a:pPr>
-            <a:r>
-              <a:t>• ✅ Заруудыг зэрэгцүүлж 1 м.кв-ын үнээр нь харьцуулах.</a:t>
-            </a:r>
-          </a:p>
-          <a:p>
-            <a:pPr>
-              <a:spcAft>
-                <a:spcPts val="800"/>
-              </a:spcAft>
-              <a:defRPr sz="1300">
-                <a:solidFill>
-                  <a:srgbClr val="FFFFFF"/>
-                </a:solidFill>
-                <a:latin typeface="Segoe UI"/>
-              </a:defRPr>
-            </a:pPr>
-            <a:r>
-              <a:t>• ✅ Үзэлт ба шэйрийн датагаар маркетингаа удирдах.</a:t>
-            </a:r>
+              <a:rPr dirty="0"/>
+              <a:t>• ✅</a:t>
+            </a:r>
+            <a:r>
+              <a:rPr dirty="0" err="1"/>
+              <a:t>Таны</a:t>
+            </a:r>
+            <a:r>
+              <a:rPr dirty="0"/>
+              <a:t> </a:t>
+            </a:r>
+            <a:r>
+              <a:rPr dirty="0" err="1"/>
+              <a:t>хайлтанд</a:t>
+            </a:r>
+            <a:r>
+              <a:rPr dirty="0"/>
+              <a:t> </a:t>
+            </a:r>
+            <a:r>
+              <a:rPr dirty="0" err="1"/>
+              <a:t>тохирох</a:t>
+            </a:r>
+            <a:r>
+              <a:rPr dirty="0"/>
+              <a:t> </a:t>
+            </a:r>
+            <a:r>
+              <a:rPr dirty="0" err="1"/>
+              <a:t>болон</a:t>
+            </a:r>
+            <a:r>
+              <a:rPr dirty="0"/>
+              <a:t> </a:t>
+            </a:r>
+            <a:r>
+              <a:rPr dirty="0" err="1"/>
+              <a:t>төсөөт</a:t>
+            </a:r>
+            <a:r>
+              <a:rPr dirty="0"/>
+              <a:t> </a:t>
+            </a:r>
+            <a:r>
+              <a:rPr dirty="0" err="1"/>
+              <a:t>зар</a:t>
+            </a:r>
+            <a:r>
+              <a:rPr dirty="0"/>
+              <a:t> </a:t>
+            </a:r>
+            <a:r>
+              <a:rPr dirty="0" err="1"/>
+              <a:t>орох</a:t>
+            </a:r>
+            <a:r>
+              <a:rPr dirty="0"/>
+              <a:t> </a:t>
+            </a:r>
+            <a:r>
+              <a:rPr dirty="0" err="1"/>
+              <a:t>үед</a:t>
+            </a:r>
+            <a:r>
+              <a:rPr dirty="0"/>
+              <a:t> </a:t>
+            </a:r>
+            <a:r>
+              <a:rPr dirty="0" err="1"/>
+              <a:t>имэйл</a:t>
+            </a:r>
+            <a:r>
+              <a:rPr dirty="0"/>
+              <a:t> </a:t>
+            </a:r>
+            <a:r>
+              <a:rPr dirty="0" err="1"/>
+              <a:t>мэдэгдэл</a:t>
+            </a:r>
+            <a:r>
+              <a:rPr dirty="0"/>
+              <a:t> </a:t>
+            </a:r>
+            <a:r>
+              <a:rPr dirty="0" err="1"/>
+              <a:t>очих</a:t>
+            </a:r>
+            <a:r>
+              <a:rPr dirty="0"/>
+              <a:t> </a:t>
+            </a:r>
+            <a:r>
+              <a:rPr dirty="0" err="1"/>
+              <a:t>болно</a:t>
+            </a:r>
+            <a:endParaRPr dirty="0"/>
           </a:p>
         </p:txBody>
       </p:sp>
@@ -3623,8 +3820,471 @@
 </p:sld>
 </file>
 
+<file path=ppt/slides/slide11.xml><?xml version="1.0" encoding="utf-8"?>
+<p:sld xmlns:a="http://schemas.openxmlformats.org/drawingml/2006/main" xmlns:r="http://schemas.openxmlformats.org/officeDocument/2006/relationships" xmlns:p="http://schemas.openxmlformats.org/presentationml/2006/main">
+  <p:cSld>
+    <p:bg>
+      <p:bgPr>
+        <a:solidFill>
+          <a:srgbClr val="0F172A"/>
+        </a:solidFill>
+        <a:effectLst/>
+      </p:bgPr>
+    </p:bg>
+    <p:spTree>
+      <p:nvGrpSpPr>
+        <p:cNvPr id="1" name="">
+          <a:extLst>
+            <a:ext uri="{FF2B5EF4-FFF2-40B4-BE49-F238E27FC236}">
+              <a16:creationId xmlns:a16="http://schemas.microsoft.com/office/drawing/2014/main" id="{CE39AC7B-9136-E5C4-EE55-3A60FA9F3FB6}"/>
+            </a:ext>
+          </a:extLst>
+        </p:cNvPr>
+        <p:cNvGrpSpPr/>
+        <p:nvPr/>
+      </p:nvGrpSpPr>
+      <p:grpSpPr>
+        <a:xfrm>
+          <a:off x="0" y="0"/>
+          <a:ext cx="0" cy="0"/>
+          <a:chOff x="0" y="0"/>
+          <a:chExt cx="0" cy="0"/>
+        </a:xfrm>
+      </p:grpSpPr>
+      <p:sp>
+        <p:nvSpPr>
+          <p:cNvPr id="2" name="TextBox 1">
+            <a:extLst>
+              <a:ext uri="{FF2B5EF4-FFF2-40B4-BE49-F238E27FC236}">
+                <a16:creationId xmlns:a16="http://schemas.microsoft.com/office/drawing/2014/main" id="{DA06C50C-CBFB-30A4-0D95-F2BC4434CE25}"/>
+              </a:ext>
+            </a:extLst>
+          </p:cNvPr>
+          <p:cNvSpPr txBox="1"/>
+          <p:nvPr/>
+        </p:nvSpPr>
+        <p:spPr>
+          <a:xfrm>
+            <a:off x="731520" y="365760"/>
+            <a:ext cx="10728655" cy="1005840"/>
+          </a:xfrm>
+          <a:prstGeom prst="rect">
+            <a:avLst/>
+          </a:prstGeom>
+          <a:noFill/>
+        </p:spPr>
+        <p:txBody>
+          <a:bodyPr wrap="square" lIns="0" tIns="0" rIns="0" bIns="0">
+            <a:spAutoFit/>
+          </a:bodyPr>
+          <a:lstStyle/>
+          <a:p>
+            <a:pPr>
+              <a:defRPr sz="2800" b="1">
+                <a:solidFill>
+                  <a:srgbClr val="FFFFFF"/>
+                </a:solidFill>
+                <a:latin typeface="Segoe UI"/>
+              </a:defRPr>
+            </a:pPr>
+            <a:r>
+              <a:t>🌐 8. Олон Хэл ба Системийн Өрсөлдөх Давуу Тал</a:t>
+            </a:r>
+          </a:p>
+          <a:p>
+            <a:pPr>
+              <a:defRPr sz="1400">
+                <a:solidFill>
+                  <a:srgbClr val="38BDF8"/>
+                </a:solidFill>
+                <a:latin typeface="Segoe UI"/>
+              </a:defRPr>
+            </a:pPr>
+            <a:r>
+              <a:t>Яагаад Vmax.mn-ийг сонгох ёстой вэ?</a:t>
+            </a:r>
+          </a:p>
+        </p:txBody>
+      </p:sp>
+      <p:sp>
+        <p:nvSpPr>
+          <p:cNvPr id="3" name="TextBox 2">
+            <a:extLst>
+              <a:ext uri="{FF2B5EF4-FFF2-40B4-BE49-F238E27FC236}">
+                <a16:creationId xmlns:a16="http://schemas.microsoft.com/office/drawing/2014/main" id="{649A3895-8B85-7584-244A-13DFC29FA0A2}"/>
+              </a:ext>
+            </a:extLst>
+          </p:cNvPr>
+          <p:cNvSpPr txBox="1"/>
+          <p:nvPr/>
+        </p:nvSpPr>
+        <p:spPr>
+          <a:xfrm>
+            <a:off x="731520" y="6400800"/>
+            <a:ext cx="10728655" cy="365760"/>
+          </a:xfrm>
+          <a:prstGeom prst="rect">
+            <a:avLst/>
+          </a:prstGeom>
+          <a:noFill/>
+        </p:spPr>
+        <p:txBody>
+          <a:bodyPr wrap="none">
+            <a:spAutoFit/>
+          </a:bodyPr>
+          <a:lstStyle/>
+          <a:p>
+            <a:pPr>
+              <a:defRPr sz="1000">
+                <a:solidFill>
+                  <a:srgbClr val="94A3B8"/>
+                </a:solidFill>
+                <a:latin typeface="Segoe UI"/>
+              </a:defRPr>
+            </a:pPr>
+            <a:r>
+              <a:t>Vmax.mn | Үл Хөдлөх Хөрөнгийн Платформ   •   Хуудас 10 / 10</a:t>
+            </a:r>
+          </a:p>
+        </p:txBody>
+      </p:sp>
+      <p:sp>
+        <p:nvSpPr>
+          <p:cNvPr id="4" name="Rounded Rectangle 3">
+            <a:extLst>
+              <a:ext uri="{FF2B5EF4-FFF2-40B4-BE49-F238E27FC236}">
+                <a16:creationId xmlns:a16="http://schemas.microsoft.com/office/drawing/2014/main" id="{17E28094-9848-EF42-ACBF-1D2CFEB4A938}"/>
+              </a:ext>
+            </a:extLst>
+          </p:cNvPr>
+          <p:cNvSpPr/>
+          <p:nvPr/>
+        </p:nvSpPr>
+        <p:spPr>
+          <a:xfrm>
+            <a:off x="731520" y="1554480"/>
+            <a:ext cx="5120640" cy="4480560"/>
+          </a:xfrm>
+          <a:prstGeom prst="roundRect">
+            <a:avLst/>
+          </a:prstGeom>
+          <a:solidFill>
+            <a:srgbClr val="1E293B"/>
+          </a:solidFill>
+          <a:ln w="19050">
+            <a:solidFill>
+              <a:srgbClr val="334155"/>
+            </a:solidFill>
+          </a:ln>
+        </p:spPr>
+        <p:style>
+          <a:lnRef idx="1">
+            <a:schemeClr val="accent1"/>
+          </a:lnRef>
+          <a:fillRef idx="3">
+            <a:schemeClr val="accent1"/>
+          </a:fillRef>
+          <a:effectRef idx="2">
+            <a:schemeClr val="accent1"/>
+          </a:effectRef>
+          <a:fontRef idx="minor">
+            <a:schemeClr val="lt1"/>
+          </a:fontRef>
+        </p:style>
+        <p:txBody>
+          <a:bodyPr rtlCol="0" anchor="ctr"/>
+          <a:lstStyle/>
+          <a:p>
+            <a:pPr algn="ctr"/>
+            <a:endParaRPr/>
+          </a:p>
+        </p:txBody>
+      </p:sp>
+      <p:sp>
+        <p:nvSpPr>
+          <p:cNvPr id="5" name="TextBox 4">
+            <a:extLst>
+              <a:ext uri="{FF2B5EF4-FFF2-40B4-BE49-F238E27FC236}">
+                <a16:creationId xmlns:a16="http://schemas.microsoft.com/office/drawing/2014/main" id="{96579C87-A5C3-E0E1-3F5B-E5DED5858905}"/>
+              </a:ext>
+            </a:extLst>
+          </p:cNvPr>
+          <p:cNvSpPr txBox="1"/>
+          <p:nvPr/>
+        </p:nvSpPr>
+        <p:spPr>
+          <a:xfrm>
+            <a:off x="1005840" y="1828800"/>
+            <a:ext cx="4572000" cy="3931920"/>
+          </a:xfrm>
+          <a:prstGeom prst="rect">
+            <a:avLst/>
+          </a:prstGeom>
+          <a:noFill/>
+        </p:spPr>
+        <p:txBody>
+          <a:bodyPr wrap="square" lIns="0" tIns="0" rIns="0" bIns="0">
+            <a:spAutoFit/>
+          </a:bodyPr>
+          <a:lstStyle/>
+          <a:p>
+            <a:pPr>
+              <a:spcAft>
+                <a:spcPts val="1200"/>
+              </a:spcAft>
+              <a:defRPr sz="1800" b="1">
+                <a:solidFill>
+                  <a:srgbClr val="38BDF8"/>
+                </a:solidFill>
+                <a:latin typeface="Segoe UI"/>
+              </a:defRPr>
+            </a:pPr>
+            <a:r>
+              <a:t>🌐 Олон Хэл &amp; Технологийн Хурд</a:t>
+            </a:r>
+          </a:p>
+          <a:p>
+            <a:pPr>
+              <a:spcAft>
+                <a:spcPts val="800"/>
+              </a:spcAft>
+              <a:defRPr sz="1300">
+                <a:solidFill>
+                  <a:srgbClr val="FFFFFF"/>
+                </a:solidFill>
+                <a:latin typeface="Segoe UI"/>
+              </a:defRPr>
+            </a:pPr>
+            <a:r>
+              <a:t>• Монгол ба Англи (MN / EN) хэлний сонголттай.</a:t>
+            </a:r>
+          </a:p>
+          <a:p>
+            <a:pPr>
+              <a:spcAft>
+                <a:spcPts val="800"/>
+              </a:spcAft>
+              <a:defRPr sz="1300">
+                <a:solidFill>
+                  <a:srgbClr val="FFFFFF"/>
+                </a:solidFill>
+                <a:latin typeface="Segoe UI"/>
+              </a:defRPr>
+            </a:pPr>
+            <a:r>
+              <a:t>• Гадаадын иргэд ба хөрөнгө оруулагчдад нээлттэй.</a:t>
+            </a:r>
+          </a:p>
+          <a:p>
+            <a:pPr>
+              <a:spcAft>
+                <a:spcPts val="800"/>
+              </a:spcAft>
+              <a:defRPr sz="1300">
+                <a:solidFill>
+                  <a:srgbClr val="FFFFFF"/>
+                </a:solidFill>
+                <a:latin typeface="Segoe UI"/>
+              </a:defRPr>
+            </a:pPr>
+            <a:r>
+              <a:t>• Single Page Application (SPA) - маш хурдан ажиллагаа.</a:t>
+            </a:r>
+          </a:p>
+          <a:p>
+            <a:pPr>
+              <a:spcAft>
+                <a:spcPts val="800"/>
+              </a:spcAft>
+              <a:defRPr sz="1300">
+                <a:solidFill>
+                  <a:srgbClr val="FFFFFF"/>
+                </a:solidFill>
+                <a:latin typeface="Segoe UI"/>
+              </a:defRPr>
+            </a:pPr>
+            <a:r>
+              <a:t>• Dark Cosmic өнгө төрх - Орчин үеийн премиум дизайн.</a:t>
+            </a:r>
+          </a:p>
+        </p:txBody>
+      </p:sp>
+      <p:sp>
+        <p:nvSpPr>
+          <p:cNvPr id="6" name="Rounded Rectangle 5">
+            <a:extLst>
+              <a:ext uri="{FF2B5EF4-FFF2-40B4-BE49-F238E27FC236}">
+                <a16:creationId xmlns:a16="http://schemas.microsoft.com/office/drawing/2014/main" id="{73F05EFA-2C3E-02FE-228F-FAF636104EF4}"/>
+              </a:ext>
+            </a:extLst>
+          </p:cNvPr>
+          <p:cNvSpPr/>
+          <p:nvPr/>
+        </p:nvSpPr>
+        <p:spPr>
+          <a:xfrm>
+            <a:off x="6339535" y="1554480"/>
+            <a:ext cx="5120640" cy="4480560"/>
+          </a:xfrm>
+          <a:prstGeom prst="roundRect">
+            <a:avLst/>
+          </a:prstGeom>
+          <a:solidFill>
+            <a:srgbClr val="1E293B"/>
+          </a:solidFill>
+          <a:ln w="19050">
+            <a:solidFill>
+              <a:srgbClr val="334155"/>
+            </a:solidFill>
+          </a:ln>
+        </p:spPr>
+        <p:style>
+          <a:lnRef idx="1">
+            <a:schemeClr val="accent1"/>
+          </a:lnRef>
+          <a:fillRef idx="3">
+            <a:schemeClr val="accent1"/>
+          </a:fillRef>
+          <a:effectRef idx="2">
+            <a:schemeClr val="accent1"/>
+          </a:effectRef>
+          <a:fontRef idx="minor">
+            <a:schemeClr val="lt1"/>
+          </a:fontRef>
+        </p:style>
+        <p:txBody>
+          <a:bodyPr rtlCol="0" anchor="ctr"/>
+          <a:lstStyle/>
+          <a:p>
+            <a:pPr algn="ctr"/>
+            <a:endParaRPr/>
+          </a:p>
+        </p:txBody>
+      </p:sp>
+      <p:sp>
+        <p:nvSpPr>
+          <p:cNvPr id="7" name="TextBox 6">
+            <a:extLst>
+              <a:ext uri="{FF2B5EF4-FFF2-40B4-BE49-F238E27FC236}">
+                <a16:creationId xmlns:a16="http://schemas.microsoft.com/office/drawing/2014/main" id="{7B2E0604-272D-DCFD-3953-E97D72674DF8}"/>
+              </a:ext>
+            </a:extLst>
+          </p:cNvPr>
+          <p:cNvSpPr txBox="1"/>
+          <p:nvPr/>
+        </p:nvSpPr>
+        <p:spPr>
+          <a:xfrm>
+            <a:off x="6613855" y="1828800"/>
+            <a:ext cx="4572000" cy="3931920"/>
+          </a:xfrm>
+          <a:prstGeom prst="rect">
+            <a:avLst/>
+          </a:prstGeom>
+          <a:noFill/>
+        </p:spPr>
+        <p:txBody>
+          <a:bodyPr wrap="square" lIns="0" tIns="0" rIns="0" bIns="0">
+            <a:spAutoFit/>
+          </a:bodyPr>
+          <a:lstStyle/>
+          <a:p>
+            <a:pPr>
+              <a:spcAft>
+                <a:spcPts val="1200"/>
+              </a:spcAft>
+              <a:defRPr sz="1800" b="1">
+                <a:solidFill>
+                  <a:srgbClr val="38BDF8"/>
+                </a:solidFill>
+                <a:latin typeface="Segoe UI"/>
+              </a:defRPr>
+            </a:pPr>
+            <a:r>
+              <a:t>🏆 Товч Дүгнэлт ба Давуу Тал</a:t>
+            </a:r>
+          </a:p>
+          <a:p>
+            <a:pPr>
+              <a:spcAft>
+                <a:spcPts val="800"/>
+              </a:spcAft>
+              <a:defRPr sz="1300">
+                <a:solidFill>
+                  <a:srgbClr val="FFFFFF"/>
+                </a:solidFill>
+                <a:latin typeface="Segoe UI"/>
+              </a:defRPr>
+            </a:pPr>
+            <a:r>
+              <a:t>• ✅ 1 минутад зар нийтлэх &amp; 1 секундэд сошиал постер бүтээх.</a:t>
+            </a:r>
+          </a:p>
+          <a:p>
+            <a:pPr>
+              <a:spcAft>
+                <a:spcPts val="800"/>
+              </a:spcAft>
+              <a:defRPr sz="1300">
+                <a:solidFill>
+                  <a:srgbClr val="FFFFFF"/>
+                </a:solidFill>
+                <a:latin typeface="Segoe UI"/>
+              </a:defRPr>
+            </a:pPr>
+            <a:r>
+              <a:t>• ✅ Видео зар хавсаргаж худалдан авагчийн итгэлцлийг олох.</a:t>
+            </a:r>
+          </a:p>
+          <a:p>
+            <a:pPr>
+              <a:spcAft>
+                <a:spcPts val="800"/>
+              </a:spcAft>
+              <a:defRPr sz="1300">
+                <a:solidFill>
+                  <a:srgbClr val="FFFFFF"/>
+                </a:solidFill>
+                <a:latin typeface="Segoe UI"/>
+              </a:defRPr>
+            </a:pPr>
+            <a:r>
+              <a:t>• ✅ Заруудыг зэрэгцүүлж 1 м.кв-ын үнээр нь харьцуулах.</a:t>
+            </a:r>
+          </a:p>
+          <a:p>
+            <a:pPr>
+              <a:spcAft>
+                <a:spcPts val="800"/>
+              </a:spcAft>
+              <a:defRPr sz="1300">
+                <a:solidFill>
+                  <a:srgbClr val="FFFFFF"/>
+                </a:solidFill>
+                <a:latin typeface="Segoe UI"/>
+              </a:defRPr>
+            </a:pPr>
+            <a:r>
+              <a:t>• ✅ Үзэлт ба шэйрийн датагаар маркетингаа удирдах.</a:t>
+            </a:r>
+          </a:p>
+        </p:txBody>
+      </p:sp>
+    </p:spTree>
+    <p:extLst>
+      <p:ext uri="{BB962C8B-B14F-4D97-AF65-F5344CB8AC3E}">
+        <p14:creationId xmlns:p14="http://schemas.microsoft.com/office/powerpoint/2010/main" val="2283103911"/>
+      </p:ext>
+    </p:extLst>
+  </p:cSld>
+  <p:clrMapOvr>
+    <a:masterClrMapping/>
+  </p:clrMapOvr>
+</p:sld>
+</file>
+
 <file path=ppt/slides/slide2.xml><?xml version="1.0" encoding="utf-8"?>
-<p:sld xmlns:a="http://schemas.openxmlformats.org/drawingml/2006/main" xmlns:p="http://schemas.openxmlformats.org/presentationml/2006/main" xmlns:r="http://schemas.openxmlformats.org/officeDocument/2006/relationships">
+<p:sld xmlns:a="http://schemas.openxmlformats.org/drawingml/2006/main" xmlns:r="http://schemas.openxmlformats.org/officeDocument/2006/relationships" xmlns:p="http://schemas.openxmlformats.org/presentationml/2006/main">
   <p:cSld>
     <p:bg>
       <p:bgPr>
@@ -3640,7 +4300,14 @@
         <p:cNvGrpSpPr/>
         <p:nvPr/>
       </p:nvGrpSpPr>
-      <p:grpSpPr/>
+      <p:grpSpPr>
+        <a:xfrm>
+          <a:off x="0" y="0"/>
+          <a:ext cx="0" cy="0"/>
+          <a:chOff x="0" y="0"/>
+          <a:chExt cx="0" cy="0"/>
+        </a:xfrm>
+      </p:grpSpPr>
       <p:sp>
         <p:nvSpPr>
           <p:cNvPr id="2" name="TextBox 1"/>
@@ -3768,6 +4435,7 @@
           <a:lstStyle/>
           <a:p>
             <a:pPr algn="ctr"/>
+            <a:endParaRPr/>
           </a:p>
         </p:txBody>
       </p:sp>
@@ -3932,6 +4600,7 @@
           <a:lstStyle/>
           <a:p>
             <a:pPr algn="ctr"/>
+            <a:endParaRPr/>
           </a:p>
         </p:txBody>
       </p:sp>
@@ -3969,8 +4638,30 @@
               </a:defRPr>
             </a:pPr>
             <a:r>
-              <a:t>✅ Vmax.mn-ийн Шинэлэг Шийдэл</a:t>
-            </a:r>
+              <a:rPr dirty="0"/>
+              <a:t>✅ Vmax.mn-</a:t>
+            </a:r>
+            <a:r>
+              <a:rPr dirty="0" err="1"/>
+              <a:t>ийн</a:t>
+            </a:r>
+            <a:r>
+              <a:rPr dirty="0"/>
+              <a:t> </a:t>
+            </a:r>
+            <a:r>
+              <a:rPr dirty="0" err="1"/>
+              <a:t>Шинэлэг</a:t>
+            </a:r>
+            <a:r>
+              <a:rPr dirty="0"/>
+              <a:t> </a:t>
+            </a:r>
+            <a:r>
+              <a:rPr dirty="0" err="1"/>
+              <a:t>Шийдэл</a:t>
+            </a:r>
+            <a:endParaRPr dirty="0"/>
           </a:p>
           <a:p>
             <a:pPr>
@@ -3985,7 +4676,72 @@
               </a:defRPr>
             </a:pPr>
             <a:r>
-              <a:t>• 1 товшилтоор сошиалд хуваалцах + Сошиал постер зураг 1 секундэд бэлтгэх.</a:t>
+              <a:rPr dirty="0"/>
+              <a:t>• 1 </a:t>
+            </a:r>
+            <a:r>
+              <a:rPr dirty="0" err="1"/>
+              <a:t>товшилтоор</a:t>
+            </a:r>
+            <a:r>
+              <a:rPr dirty="0"/>
+              <a:t> </a:t>
+            </a:r>
+            <a:r>
+              <a:rPr dirty="0" err="1"/>
+              <a:t>сошиалд</a:t>
+            </a:r>
+            <a:r>
+              <a:rPr dirty="0"/>
+              <a:t> </a:t>
+            </a:r>
+            <a:r>
+              <a:rPr dirty="0" err="1"/>
+              <a:t>хуваалцах</a:t>
+            </a:r>
+            <a:r>
+              <a:rPr dirty="0"/>
+              <a:t> + </a:t>
+            </a:r>
+            <a:r>
+              <a:rPr dirty="0" err="1"/>
+              <a:t>Сошиал</a:t>
+            </a:r>
+            <a:r>
+              <a:rPr dirty="0"/>
+              <a:t> </a:t>
+            </a:r>
+            <a:r>
+              <a:rPr dirty="0" err="1"/>
+              <a:t>постер</a:t>
+            </a:r>
+            <a:r>
+              <a:rPr dirty="0"/>
+              <a:t> </a:t>
+            </a:r>
+            <a:r>
+              <a:rPr dirty="0" err="1"/>
+              <a:t>зураг</a:t>
+            </a:r>
+            <a:r>
+              <a:rPr dirty="0"/>
+              <a:t> 1 </a:t>
+            </a:r>
+            <a:r>
+              <a:rPr dirty="0" err="1"/>
+              <a:t>секундэд</a:t>
+            </a:r>
+            <a:r>
+              <a:rPr dirty="0"/>
+              <a:t> </a:t>
+            </a:r>
+            <a:r>
+              <a:rPr dirty="0" err="1"/>
+              <a:t>бэлтгэх</a:t>
+            </a:r>
+            <a:r>
+              <a:rPr dirty="0"/>
+              <a:t>.</a:t>
             </a:r>
           </a:p>
           <a:p>
@@ -4001,7 +4757,64 @@
               </a:defRPr>
             </a:pPr>
             <a:r>
-              <a:t>• Facebook Open Graph Card-аар зарын зураг, үнэ сошиалд тунгалаг харагдана.</a:t>
+              <a:rPr dirty="0"/>
+              <a:t>• Facebook Open Graph Card-</a:t>
+            </a:r>
+            <a:r>
+              <a:rPr dirty="0" err="1"/>
+              <a:t>аар</a:t>
+            </a:r>
+            <a:r>
+              <a:rPr dirty="0"/>
+              <a:t> </a:t>
+            </a:r>
+            <a:r>
+              <a:rPr dirty="0" err="1"/>
+              <a:t>зарын</a:t>
+            </a:r>
+            <a:r>
+              <a:rPr dirty="0"/>
+              <a:t> </a:t>
+            </a:r>
+            <a:r>
+              <a:rPr dirty="0" err="1"/>
+              <a:t>зураг</a:t>
+            </a:r>
+            <a:r>
+              <a:rPr dirty="0"/>
+              <a:t>, </a:t>
+            </a:r>
+            <a:r>
+              <a:rPr dirty="0" err="1"/>
+              <a:t>үнэ</a:t>
+            </a:r>
+            <a:r>
+              <a:rPr dirty="0"/>
+              <a:t> </a:t>
+            </a:r>
+            <a:r>
+              <a:rPr dirty="0" err="1"/>
+              <a:t>сошиалд</a:t>
+            </a:r>
+            <a:r>
+              <a:rPr dirty="0"/>
+              <a:t> </a:t>
+            </a:r>
+            <a:r>
+              <a:rPr dirty="0" err="1"/>
+              <a:t>тунгалаг</a:t>
+            </a:r>
+            <a:r>
+              <a:rPr dirty="0"/>
+              <a:t> </a:t>
+            </a:r>
+            <a:r>
+              <a:rPr dirty="0" err="1"/>
+              <a:t>харагдана</a:t>
+            </a:r>
+            <a:r>
+              <a:rPr dirty="0"/>
+              <a:t>.</a:t>
             </a:r>
           </a:p>
           <a:p>
@@ -4017,7 +4830,72 @@
               </a:defRPr>
             </a:pPr>
             <a:r>
-              <a:t>• Видео зар ба виртуал аялал хавсаргаж итгэлцлийг 300% нэмэгдүүлнэ.</a:t>
+              <a:rPr dirty="0"/>
+              <a:t>• </a:t>
+            </a:r>
+            <a:r>
+              <a:rPr dirty="0" err="1"/>
+              <a:t>Видео</a:t>
+            </a:r>
+            <a:r>
+              <a:rPr dirty="0"/>
+              <a:t> </a:t>
+            </a:r>
+            <a:r>
+              <a:rPr dirty="0" err="1"/>
+              <a:t>зар</a:t>
+            </a:r>
+            <a:r>
+              <a:rPr dirty="0"/>
+              <a:t> </a:t>
+            </a:r>
+            <a:r>
+              <a:rPr dirty="0" err="1"/>
+              <a:t>ба</a:t>
+            </a:r>
+            <a:r>
+              <a:rPr dirty="0"/>
+              <a:t> </a:t>
+            </a:r>
+            <a:r>
+              <a:rPr dirty="0" err="1"/>
+              <a:t>виртуал</a:t>
+            </a:r>
+            <a:r>
+              <a:rPr dirty="0"/>
+              <a:t> </a:t>
+            </a:r>
+            <a:r>
+              <a:rPr dirty="0" err="1"/>
+              <a:t>аялал</a:t>
+            </a:r>
+            <a:r>
+              <a:rPr dirty="0"/>
+              <a:t> </a:t>
+            </a:r>
+            <a:r>
+              <a:rPr dirty="0" err="1"/>
+              <a:t>хавсаргаж</a:t>
+            </a:r>
+            <a:r>
+              <a:rPr dirty="0"/>
+              <a:t> </a:t>
+            </a:r>
+            <a:r>
+              <a:rPr dirty="0" err="1"/>
+              <a:t>итгэлцлийг</a:t>
+            </a:r>
+            <a:r>
+              <a:rPr dirty="0"/>
+              <a:t> 300% </a:t>
+            </a:r>
+            <a:r>
+              <a:rPr dirty="0" err="1"/>
+              <a:t>нэмэгдүүлнэ</a:t>
+            </a:r>
+            <a:r>
+              <a:rPr dirty="0"/>
+              <a:t>.</a:t>
             </a:r>
           </a:p>
           <a:p>
@@ -4033,7 +4911,80 @@
               </a:defRPr>
             </a:pPr>
             <a:r>
-              <a:t>• Үзэлтийн тоо болон Сошиалд хуваалцсан тоог (Shares) бодит цагаар хянана.</a:t>
+              <a:rPr dirty="0"/>
+              <a:t>• </a:t>
+            </a:r>
+            <a:r>
+              <a:rPr dirty="0" err="1"/>
+              <a:t>Үзэлтийн</a:t>
+            </a:r>
+            <a:r>
+              <a:rPr dirty="0"/>
+              <a:t> </a:t>
+            </a:r>
+            <a:r>
+              <a:rPr dirty="0" err="1"/>
+              <a:t>тоо</a:t>
+            </a:r>
+            <a:r>
+              <a:rPr dirty="0"/>
+              <a:t> </a:t>
+            </a:r>
+            <a:r>
+              <a:rPr dirty="0" err="1"/>
+              <a:t>болон</a:t>
+            </a:r>
+            <a:r>
+              <a:rPr dirty="0"/>
+              <a:t> </a:t>
+            </a:r>
+            <a:r>
+              <a:rPr dirty="0" err="1"/>
+              <a:t>Сошиалд</a:t>
+            </a:r>
+            <a:r>
+              <a:rPr dirty="0"/>
+              <a:t> </a:t>
+            </a:r>
+            <a:r>
+              <a:rPr dirty="0" err="1"/>
+              <a:t>хуваалцсан</a:t>
+            </a:r>
+            <a:r>
+              <a:rPr dirty="0"/>
+              <a:t> </a:t>
+            </a:r>
+            <a:r>
+              <a:rPr dirty="0" err="1"/>
+              <a:t>тоог</a:t>
+            </a:r>
+            <a:r>
+              <a:rPr dirty="0"/>
+              <a:t> (Shares) </a:t>
+            </a:r>
+            <a:r>
+              <a:rPr dirty="0" err="1"/>
+              <a:t>бодит</a:t>
+            </a:r>
+            <a:r>
+              <a:rPr dirty="0"/>
+              <a:t> </a:t>
+            </a:r>
+            <a:r>
+              <a:rPr dirty="0" err="1"/>
+              <a:t>цагаар</a:t>
+            </a:r>
+            <a:r>
+              <a:rPr dirty="0"/>
+              <a:t> </a:t>
+            </a:r>
+            <a:r>
+              <a:rPr dirty="0" err="1"/>
+              <a:t>хянана</a:t>
+            </a:r>
+            <a:r>
+              <a:rPr dirty="0"/>
+              <a:t>.</a:t>
             </a:r>
           </a:p>
           <a:p>
@@ -4049,7 +5000,80 @@
               </a:defRPr>
             </a:pPr>
             <a:r>
-              <a:t>• Заруудыг зэрэгцүүлж 1 м.кв-ын үнэ ба онцлогоор нь шүүн харьцуулна.</a:t>
+              <a:rPr dirty="0"/>
+              <a:t>• </a:t>
+            </a:r>
+            <a:r>
+              <a:rPr dirty="0" err="1"/>
+              <a:t>Заруудыг</a:t>
+            </a:r>
+            <a:r>
+              <a:rPr dirty="0"/>
+              <a:t> </a:t>
+            </a:r>
+            <a:r>
+              <a:rPr dirty="0" err="1"/>
+              <a:t>зэрэгцүүлж</a:t>
+            </a:r>
+            <a:r>
+              <a:rPr dirty="0"/>
+              <a:t> 1 </a:t>
+            </a:r>
+            <a:r>
+              <a:rPr dirty="0" err="1"/>
+              <a:t>м.кв-ын</a:t>
+            </a:r>
+            <a:r>
+              <a:rPr dirty="0"/>
+              <a:t> </a:t>
+            </a:r>
+            <a:r>
+              <a:rPr dirty="0" err="1"/>
+              <a:t>үнэ</a:t>
+            </a:r>
+            <a:r>
+              <a:rPr dirty="0"/>
+              <a:t> </a:t>
+            </a:r>
+            <a:r>
+              <a:rPr dirty="0" err="1"/>
+              <a:t>ба</a:t>
+            </a:r>
+            <a:r>
+              <a:rPr dirty="0"/>
+              <a:t> </a:t>
+            </a:r>
+            <a:r>
+              <a:rPr dirty="0" err="1"/>
+              <a:t>онцлогоор</a:t>
+            </a:r>
+            <a:r>
+              <a:rPr dirty="0"/>
+              <a:t> </a:t>
+            </a:r>
+            <a:r>
+              <a:rPr dirty="0" err="1"/>
+              <a:t>нь</a:t>
+            </a:r>
+            <a:r>
+              <a:rPr dirty="0"/>
+              <a:t> </a:t>
+            </a:r>
+            <a:r>
+              <a:rPr dirty="0" err="1"/>
+              <a:t>шүүн</a:t>
+            </a:r>
+            <a:r>
+              <a:rPr dirty="0"/>
+              <a:t> </a:t>
+            </a:r>
+            <a:r>
+              <a:rPr dirty="0" err="1"/>
+              <a:t>харьцуулна</a:t>
+            </a:r>
+            <a:r>
+              <a:rPr dirty="0"/>
+              <a:t>.</a:t>
             </a:r>
           </a:p>
         </p:txBody>
@@ -4063,7 +5087,7 @@
 </file>
 
 <file path=ppt/slides/slide3.xml><?xml version="1.0" encoding="utf-8"?>
-<p:sld xmlns:a="http://schemas.openxmlformats.org/drawingml/2006/main" xmlns:p="http://schemas.openxmlformats.org/presentationml/2006/main" xmlns:r="http://schemas.openxmlformats.org/officeDocument/2006/relationships">
+<p:sld xmlns:a="http://schemas.openxmlformats.org/drawingml/2006/main" xmlns:r="http://schemas.openxmlformats.org/officeDocument/2006/relationships" xmlns:p="http://schemas.openxmlformats.org/presentationml/2006/main">
   <p:cSld>
     <p:bg>
       <p:bgPr>
@@ -4079,7 +5103,14 @@
         <p:cNvGrpSpPr/>
         <p:nvPr/>
       </p:nvGrpSpPr>
-      <p:grpSpPr/>
+      <p:grpSpPr>
+        <a:xfrm>
+          <a:off x="0" y="0"/>
+          <a:ext cx="0" cy="0"/>
+          <a:chOff x="0" y="0"/>
+          <a:chExt cx="0" cy="0"/>
+        </a:xfrm>
+      </p:grpSpPr>
       <p:sp>
         <p:nvSpPr>
           <p:cNvPr id="2" name="TextBox 1"/>
@@ -4207,6 +5238,7 @@
           <a:lstStyle/>
           <a:p>
             <a:pPr algn="ctr"/>
+            <a:endParaRPr/>
           </a:p>
         </p:txBody>
       </p:sp>
@@ -4387,6 +5419,7 @@
           <a:lstStyle/>
           <a:p>
             <a:pPr algn="ctr"/>
+            <a:endParaRPr/>
           </a:p>
         </p:txBody>
       </p:sp>
@@ -4535,6 +5568,7 @@
           <a:lstStyle/>
           <a:p>
             <a:pPr algn="ctr"/>
+            <a:endParaRPr/>
           </a:p>
         </p:txBody>
       </p:sp>
@@ -4634,7 +5668,7 @@
 </file>
 
 <file path=ppt/slides/slide4.xml><?xml version="1.0" encoding="utf-8"?>
-<p:sld xmlns:a="http://schemas.openxmlformats.org/drawingml/2006/main" xmlns:p="http://schemas.openxmlformats.org/presentationml/2006/main" xmlns:r="http://schemas.openxmlformats.org/officeDocument/2006/relationships">
+<p:sld xmlns:a="http://schemas.openxmlformats.org/drawingml/2006/main" xmlns:r="http://schemas.openxmlformats.org/officeDocument/2006/relationships" xmlns:p="http://schemas.openxmlformats.org/presentationml/2006/main">
   <p:cSld>
     <p:bg>
       <p:bgPr>
@@ -4650,7 +5684,14 @@
         <p:cNvGrpSpPr/>
         <p:nvPr/>
       </p:nvGrpSpPr>
-      <p:grpSpPr/>
+      <p:grpSpPr>
+        <a:xfrm>
+          <a:off x="0" y="0"/>
+          <a:ext cx="0" cy="0"/>
+          <a:chOff x="0" y="0"/>
+          <a:chExt cx="0" cy="0"/>
+        </a:xfrm>
+      </p:grpSpPr>
       <p:sp>
         <p:nvSpPr>
           <p:cNvPr id="2" name="TextBox 1"/>
@@ -4778,6 +5819,7 @@
           <a:lstStyle/>
           <a:p>
             <a:pPr algn="ctr"/>
+            <a:endParaRPr/>
           </a:p>
         </p:txBody>
       </p:sp>
@@ -4926,6 +5968,7 @@
           <a:lstStyle/>
           <a:p>
             <a:pPr algn="ctr"/>
+            <a:endParaRPr/>
           </a:p>
         </p:txBody>
       </p:sp>
@@ -5041,7 +6084,7 @@
 </file>
 
 <file path=ppt/slides/slide5.xml><?xml version="1.0" encoding="utf-8"?>
-<p:sld xmlns:a="http://schemas.openxmlformats.org/drawingml/2006/main" xmlns:p="http://schemas.openxmlformats.org/presentationml/2006/main" xmlns:r="http://schemas.openxmlformats.org/officeDocument/2006/relationships">
+<p:sld xmlns:a="http://schemas.openxmlformats.org/drawingml/2006/main" xmlns:r="http://schemas.openxmlformats.org/officeDocument/2006/relationships" xmlns:p="http://schemas.openxmlformats.org/presentationml/2006/main">
   <p:cSld>
     <p:bg>
       <p:bgPr>
@@ -5057,7 +6100,14 @@
         <p:cNvGrpSpPr/>
         <p:nvPr/>
       </p:nvGrpSpPr>
-      <p:grpSpPr/>
+      <p:grpSpPr>
+        <a:xfrm>
+          <a:off x="0" y="0"/>
+          <a:ext cx="0" cy="0"/>
+          <a:chOff x="0" y="0"/>
+          <a:chExt cx="0" cy="0"/>
+        </a:xfrm>
+      </p:grpSpPr>
       <p:sp>
         <p:nvSpPr>
           <p:cNvPr id="2" name="TextBox 1"/>
@@ -5185,6 +6235,7 @@
           <a:lstStyle/>
           <a:p>
             <a:pPr algn="ctr"/>
+            <a:endParaRPr/>
           </a:p>
         </p:txBody>
       </p:sp>
@@ -5349,6 +6400,7 @@
           <a:lstStyle/>
           <a:p>
             <a:pPr algn="ctr"/>
+            <a:endParaRPr/>
           </a:p>
         </p:txBody>
       </p:sp>
@@ -5464,7 +6516,7 @@
 </file>
 
 <file path=ppt/slides/slide6.xml><?xml version="1.0" encoding="utf-8"?>
-<p:sld xmlns:a="http://schemas.openxmlformats.org/drawingml/2006/main" xmlns:p="http://schemas.openxmlformats.org/presentationml/2006/main" xmlns:r="http://schemas.openxmlformats.org/officeDocument/2006/relationships">
+<p:sld xmlns:a="http://schemas.openxmlformats.org/drawingml/2006/main" xmlns:r="http://schemas.openxmlformats.org/officeDocument/2006/relationships" xmlns:p="http://schemas.openxmlformats.org/presentationml/2006/main">
   <p:cSld>
     <p:bg>
       <p:bgPr>
@@ -5480,7 +6532,14 @@
         <p:cNvGrpSpPr/>
         <p:nvPr/>
       </p:nvGrpSpPr>
-      <p:grpSpPr/>
+      <p:grpSpPr>
+        <a:xfrm>
+          <a:off x="0" y="0"/>
+          <a:ext cx="0" cy="0"/>
+          <a:chOff x="0" y="0"/>
+          <a:chExt cx="0" cy="0"/>
+        </a:xfrm>
+      </p:grpSpPr>
       <p:sp>
         <p:nvSpPr>
           <p:cNvPr id="2" name="TextBox 1"/>
@@ -5608,6 +6667,7 @@
           <a:lstStyle/>
           <a:p>
             <a:pPr algn="ctr"/>
+            <a:endParaRPr/>
           </a:p>
         </p:txBody>
       </p:sp>
@@ -5756,6 +6816,7 @@
           <a:lstStyle/>
           <a:p>
             <a:pPr algn="ctr"/>
+            <a:endParaRPr/>
           </a:p>
         </p:txBody>
       </p:sp>
@@ -5904,6 +6965,7 @@
           <a:lstStyle/>
           <a:p>
             <a:pPr algn="ctr"/>
+            <a:endParaRPr/>
           </a:p>
         </p:txBody>
       </p:sp>
@@ -6003,7 +7065,7 @@
 </file>
 
 <file path=ppt/slides/slide7.xml><?xml version="1.0" encoding="utf-8"?>
-<p:sld xmlns:a="http://schemas.openxmlformats.org/drawingml/2006/main" xmlns:p="http://schemas.openxmlformats.org/presentationml/2006/main" xmlns:r="http://schemas.openxmlformats.org/officeDocument/2006/relationships">
+<p:sld xmlns:a="http://schemas.openxmlformats.org/drawingml/2006/main" xmlns:r="http://schemas.openxmlformats.org/officeDocument/2006/relationships" xmlns:p="http://schemas.openxmlformats.org/presentationml/2006/main">
   <p:cSld>
     <p:bg>
       <p:bgPr>
@@ -6019,7 +7081,14 @@
         <p:cNvGrpSpPr/>
         <p:nvPr/>
       </p:nvGrpSpPr>
-      <p:grpSpPr/>
+      <p:grpSpPr>
+        <a:xfrm>
+          <a:off x="0" y="0"/>
+          <a:ext cx="0" cy="0"/>
+          <a:chOff x="0" y="0"/>
+          <a:chExt cx="0" cy="0"/>
+        </a:xfrm>
+      </p:grpSpPr>
       <p:sp>
         <p:nvSpPr>
           <p:cNvPr id="2" name="TextBox 1"/>
@@ -6147,6 +7216,7 @@
           <a:lstStyle/>
           <a:p>
             <a:pPr algn="ctr"/>
+            <a:endParaRPr/>
           </a:p>
         </p:txBody>
       </p:sp>
@@ -6295,6 +7365,7 @@
           <a:lstStyle/>
           <a:p>
             <a:pPr algn="ctr"/>
+            <a:endParaRPr/>
           </a:p>
         </p:txBody>
       </p:sp>
@@ -6410,7 +7481,7 @@
 </file>
 
 <file path=ppt/slides/slide8.xml><?xml version="1.0" encoding="utf-8"?>
-<p:sld xmlns:a="http://schemas.openxmlformats.org/drawingml/2006/main" xmlns:p="http://schemas.openxmlformats.org/presentationml/2006/main" xmlns:r="http://schemas.openxmlformats.org/officeDocument/2006/relationships">
+<p:sld xmlns:a="http://schemas.openxmlformats.org/drawingml/2006/main" xmlns:r="http://schemas.openxmlformats.org/officeDocument/2006/relationships" xmlns:p="http://schemas.openxmlformats.org/presentationml/2006/main">
   <p:cSld>
     <p:bg>
       <p:bgPr>
@@ -6426,7 +7497,14 @@
         <p:cNvGrpSpPr/>
         <p:nvPr/>
       </p:nvGrpSpPr>
-      <p:grpSpPr/>
+      <p:grpSpPr>
+        <a:xfrm>
+          <a:off x="0" y="0"/>
+          <a:ext cx="0" cy="0"/>
+          <a:chOff x="0" y="0"/>
+          <a:chExt cx="0" cy="0"/>
+        </a:xfrm>
+      </p:grpSpPr>
       <p:sp>
         <p:nvSpPr>
           <p:cNvPr id="2" name="TextBox 1"/>
@@ -6554,6 +7632,7 @@
           <a:lstStyle/>
           <a:p>
             <a:pPr algn="ctr"/>
+            <a:endParaRPr/>
           </a:p>
         </p:txBody>
       </p:sp>
@@ -6702,6 +7781,7 @@
           <a:lstStyle/>
           <a:p>
             <a:pPr algn="ctr"/>
+            <a:endParaRPr/>
           </a:p>
         </p:txBody>
       </p:sp>
@@ -6833,7 +7913,7 @@
 </file>
 
 <file path=ppt/slides/slide9.xml><?xml version="1.0" encoding="utf-8"?>
-<p:sld xmlns:a="http://schemas.openxmlformats.org/drawingml/2006/main" xmlns:p="http://schemas.openxmlformats.org/presentationml/2006/main" xmlns:r="http://schemas.openxmlformats.org/officeDocument/2006/relationships">
+<p:sld xmlns:a="http://schemas.openxmlformats.org/drawingml/2006/main" xmlns:r="http://schemas.openxmlformats.org/officeDocument/2006/relationships" xmlns:p="http://schemas.openxmlformats.org/presentationml/2006/main">
   <p:cSld>
     <p:bg>
       <p:bgPr>
@@ -6849,7 +7929,14 @@
         <p:cNvGrpSpPr/>
         <p:nvPr/>
       </p:nvGrpSpPr>
-      <p:grpSpPr/>
+      <p:grpSpPr>
+        <a:xfrm>
+          <a:off x="0" y="0"/>
+          <a:ext cx="0" cy="0"/>
+          <a:chOff x="0" y="0"/>
+          <a:chExt cx="0" cy="0"/>
+        </a:xfrm>
+      </p:grpSpPr>
       <p:sp>
         <p:nvSpPr>
           <p:cNvPr id="2" name="TextBox 1"/>
@@ -6977,6 +8064,7 @@
           <a:lstStyle/>
           <a:p>
             <a:pPr algn="ctr"/>
+            <a:endParaRPr/>
           </a:p>
         </p:txBody>
       </p:sp>
@@ -7125,6 +8213,7 @@
           <a:lstStyle/>
           <a:p>
             <a:pPr algn="ctr"/>
+            <a:endParaRPr/>
           </a:p>
         </p:txBody>
       </p:sp>

</xml_diff>